<commit_message>
Update Plotly graph IDs and Polish translations in HTML report for model aggregation metrics
</commit_message>
<xml_diff>
--- a/docs/Wine_Quality_Prezentacja.pptx
+++ b/docs/Wine_Quality_Prezentacja.pptx
@@ -321,7 +321,7 @@
           <a:p>
             <a:fld id="{5BCAD085-E8A6-8845-BD4E-CB4CCA059FC4}" type="datetimeFigureOut">
               <a:rPr lang="en-US" smtClean="0"/>
-              <a:t>5/2/26</a:t>
+              <a:t>5/11/26</a:t>
             </a:fld>
             <a:endParaRPr lang="en-US"/>
           </a:p>
@@ -489,7 +489,7 @@
           <a:p>
             <a:fld id="{5BCAD085-E8A6-8845-BD4E-CB4CCA059FC4}" type="datetimeFigureOut">
               <a:rPr lang="en-US" smtClean="0"/>
-              <a:t>5/2/26</a:t>
+              <a:t>5/11/26</a:t>
             </a:fld>
             <a:endParaRPr lang="en-US"/>
           </a:p>
@@ -667,7 +667,7 @@
           <a:p>
             <a:fld id="{5BCAD085-E8A6-8845-BD4E-CB4CCA059FC4}" type="datetimeFigureOut">
               <a:rPr lang="en-US" smtClean="0"/>
-              <a:t>5/2/26</a:t>
+              <a:t>5/11/26</a:t>
             </a:fld>
             <a:endParaRPr lang="en-US"/>
           </a:p>
@@ -835,7 +835,7 @@
           <a:p>
             <a:fld id="{5BCAD085-E8A6-8845-BD4E-CB4CCA059FC4}" type="datetimeFigureOut">
               <a:rPr lang="en-US" smtClean="0"/>
-              <a:t>5/2/26</a:t>
+              <a:t>5/11/26</a:t>
             </a:fld>
             <a:endParaRPr lang="en-US"/>
           </a:p>
@@ -1080,7 +1080,7 @@
           <a:p>
             <a:fld id="{5BCAD085-E8A6-8845-BD4E-CB4CCA059FC4}" type="datetimeFigureOut">
               <a:rPr lang="en-US" smtClean="0"/>
-              <a:t>5/2/26</a:t>
+              <a:t>5/11/26</a:t>
             </a:fld>
             <a:endParaRPr lang="en-US"/>
           </a:p>
@@ -1365,7 +1365,7 @@
           <a:p>
             <a:fld id="{5BCAD085-E8A6-8845-BD4E-CB4CCA059FC4}" type="datetimeFigureOut">
               <a:rPr lang="en-US" smtClean="0"/>
-              <a:t>5/2/26</a:t>
+              <a:t>5/11/26</a:t>
             </a:fld>
             <a:endParaRPr lang="en-US"/>
           </a:p>
@@ -1784,7 +1784,7 @@
           <a:p>
             <a:fld id="{5BCAD085-E8A6-8845-BD4E-CB4CCA059FC4}" type="datetimeFigureOut">
               <a:rPr lang="en-US" smtClean="0"/>
-              <a:t>5/2/26</a:t>
+              <a:t>5/11/26</a:t>
             </a:fld>
             <a:endParaRPr lang="en-US"/>
           </a:p>
@@ -1901,7 +1901,7 @@
           <a:p>
             <a:fld id="{5BCAD085-E8A6-8845-BD4E-CB4CCA059FC4}" type="datetimeFigureOut">
               <a:rPr lang="en-US" smtClean="0"/>
-              <a:t>5/2/26</a:t>
+              <a:t>5/11/26</a:t>
             </a:fld>
             <a:endParaRPr lang="en-US"/>
           </a:p>
@@ -1996,7 +1996,7 @@
           <a:p>
             <a:fld id="{5BCAD085-E8A6-8845-BD4E-CB4CCA059FC4}" type="datetimeFigureOut">
               <a:rPr lang="en-US" smtClean="0"/>
-              <a:t>5/2/26</a:t>
+              <a:t>5/11/26</a:t>
             </a:fld>
             <a:endParaRPr lang="en-US"/>
           </a:p>
@@ -2271,7 +2271,7 @@
           <a:p>
             <a:fld id="{5BCAD085-E8A6-8845-BD4E-CB4CCA059FC4}" type="datetimeFigureOut">
               <a:rPr lang="en-US" smtClean="0"/>
-              <a:t>5/2/26</a:t>
+              <a:t>5/11/26</a:t>
             </a:fld>
             <a:endParaRPr lang="en-US"/>
           </a:p>
@@ -2523,7 +2523,7 @@
           <a:p>
             <a:fld id="{5BCAD085-E8A6-8845-BD4E-CB4CCA059FC4}" type="datetimeFigureOut">
               <a:rPr lang="en-US" smtClean="0"/>
-              <a:t>5/2/26</a:t>
+              <a:t>5/11/26</a:t>
             </a:fld>
             <a:endParaRPr lang="en-US"/>
           </a:p>
@@ -2734,7 +2734,7 @@
           <a:p>
             <a:fld id="{5BCAD085-E8A6-8845-BD4E-CB4CCA059FC4}" type="datetimeFigureOut">
               <a:rPr lang="en-US" smtClean="0"/>
-              <a:t>5/2/26</a:t>
+              <a:t>5/11/26</a:t>
             </a:fld>
             <a:endParaRPr lang="en-US"/>
           </a:p>
@@ -24403,7 +24403,7 @@
         </p:nvSpPr>
         <p:spPr>
           <a:xfrm>
-            <a:off x="305" y="164592"/>
+            <a:off x="-8468" y="164592"/>
             <a:ext cx="12191695" cy="6858000"/>
           </a:xfrm>
           <a:prstGeom prst="rect">
@@ -24605,7 +24605,7 @@
         </p:nvSpPr>
         <p:spPr>
           <a:xfrm>
-            <a:off x="0" y="6565392"/>
+            <a:off x="0" y="6750494"/>
             <a:ext cx="12191695" cy="292608"/>
           </a:xfrm>
           <a:prstGeom prst="rect">
@@ -24649,7 +24649,7 @@
         </p:nvSpPr>
         <p:spPr>
           <a:xfrm>
-            <a:off x="457200" y="6592824"/>
+            <a:off x="457200" y="6777926"/>
             <a:ext cx="7315200" cy="274320"/>
           </a:xfrm>
           <a:prstGeom prst="rect">
@@ -24684,7 +24684,7 @@
         </p:nvSpPr>
         <p:spPr>
           <a:xfrm>
-            <a:off x="10820095" y="6592824"/>
+            <a:off x="10789920" y="6858000"/>
             <a:ext cx="914400" cy="274320"/>
           </a:xfrm>
           <a:prstGeom prst="rect">
@@ -24700,7 +24700,7 @@
           <a:p>
             <a:pPr algn="r"/>
             <a:r>
-              <a:rPr sz="900" b="1" i="0">
+              <a:rPr sz="900" b="1" i="0" dirty="0">
                 <a:solidFill>
                   <a:srgbClr val="C9A227"/>
                 </a:solidFill>
@@ -27886,7 +27886,7 @@
         </p:nvSpPr>
         <p:spPr>
           <a:xfrm>
-            <a:off x="0" y="0"/>
+            <a:off x="-8467" y="0"/>
             <a:ext cx="12191695" cy="6858000"/>
           </a:xfrm>
           <a:prstGeom prst="rect">
@@ -29044,7 +29044,7 @@
         </p:nvSpPr>
         <p:spPr>
           <a:xfrm>
-            <a:off x="457200" y="3429000"/>
+            <a:off x="448733" y="3420533"/>
             <a:ext cx="11247120" cy="1920240"/>
           </a:xfrm>
           <a:prstGeom prst="rect">
@@ -29083,7 +29083,7 @@
         </p:nvSpPr>
         <p:spPr>
           <a:xfrm>
-            <a:off x="457200" y="5486400"/>
+            <a:off x="472287" y="4946904"/>
             <a:ext cx="11247120" cy="365760"/>
           </a:xfrm>
           <a:prstGeom prst="rect">
@@ -29099,13 +29099,58 @@
           <a:p>
             <a:pPr algn="l"/>
             <a:r>
-              <a:rPr sz="1400" b="1" i="0">
+              <a:rPr sz="1400" b="1" i="0" dirty="0" err="1">
                 <a:solidFill>
                   <a:srgbClr val="7A1F3A"/>
                 </a:solidFill>
                 <a:latin typeface="Calibri"/>
               </a:rPr>
-              <a:t>Struktura kodu w repozytorium:</a:t>
+              <a:t>Struktura</a:t>
+            </a:r>
+            <a:r>
+              <a:rPr sz="1400" b="1" i="0" dirty="0">
+                <a:solidFill>
+                  <a:srgbClr val="7A1F3A"/>
+                </a:solidFill>
+                <a:latin typeface="Calibri"/>
+              </a:rPr>
+              <a:t> </a:t>
+            </a:r>
+            <a:r>
+              <a:rPr sz="1400" b="1" i="0" dirty="0" err="1">
+                <a:solidFill>
+                  <a:srgbClr val="7A1F3A"/>
+                </a:solidFill>
+                <a:latin typeface="Calibri"/>
+              </a:rPr>
+              <a:t>kodu</a:t>
+            </a:r>
+            <a:r>
+              <a:rPr sz="1400" b="1" i="0" dirty="0">
+                <a:solidFill>
+                  <a:srgbClr val="7A1F3A"/>
+                </a:solidFill>
+                <a:latin typeface="Calibri"/>
+              </a:rPr>
+              <a:t> w </a:t>
+            </a:r>
+            <a:r>
+              <a:rPr sz="1400" b="1" i="0" dirty="0" err="1">
+                <a:solidFill>
+                  <a:srgbClr val="7A1F3A"/>
+                </a:solidFill>
+                <a:latin typeface="Calibri"/>
+              </a:rPr>
+              <a:t>repozytorium</a:t>
+            </a:r>
+            <a:r>
+              <a:rPr sz="1400" b="1" i="0" dirty="0">
+                <a:solidFill>
+                  <a:srgbClr val="7A1F3A"/>
+                </a:solidFill>
+                <a:latin typeface="Calibri"/>
+              </a:rPr>
+              <a:t>:</a:t>
             </a:r>
           </a:p>
         </p:txBody>
@@ -29118,7 +29163,7 @@
         </p:nvSpPr>
         <p:spPr>
           <a:xfrm>
-            <a:off x="457200" y="5852160"/>
+            <a:off x="457200" y="5221224"/>
             <a:ext cx="11247120" cy="1005840"/>
           </a:xfrm>
           <a:prstGeom prst="rect">
@@ -29141,7 +29186,7 @@
               </a:spcAft>
             </a:pPr>
             <a:r>
-              <a:rPr sz="1100" b="1">
+              <a:rPr sz="1100" b="1" dirty="0">
                 <a:solidFill>
                   <a:srgbClr val="7A1F3A"/>
                 </a:solidFill>
@@ -29150,13 +29195,148 @@
               <a:t>•  </a:t>
             </a:r>
             <a:r>
-              <a:rPr sz="1100">
-                <a:solidFill>
-                  <a:srgbClr val="1F2A44"/>
-                </a:solidFill>
-                <a:latin typeface="Calibri"/>
-              </a:rPr>
-              <a:t>src/config.py — ścieżki do plików oraz RANDOM_STATE = 42 (jeden seed na całość).</a:t>
+              <a:rPr sz="1100" dirty="0" err="1">
+                <a:solidFill>
+                  <a:srgbClr val="1F2A44"/>
+                </a:solidFill>
+                <a:latin typeface="Calibri"/>
+              </a:rPr>
+              <a:t>src</a:t>
+            </a:r>
+            <a:r>
+              <a:rPr sz="1100" dirty="0">
+                <a:solidFill>
+                  <a:srgbClr val="1F2A44"/>
+                </a:solidFill>
+                <a:latin typeface="Calibri"/>
+              </a:rPr>
+              <a:t>/</a:t>
+            </a:r>
+            <a:r>
+              <a:rPr sz="1100" dirty="0" err="1">
+                <a:solidFill>
+                  <a:srgbClr val="1F2A44"/>
+                </a:solidFill>
+                <a:latin typeface="Calibri"/>
+              </a:rPr>
+              <a:t>config.py</a:t>
+            </a:r>
+            <a:r>
+              <a:rPr sz="1100" dirty="0">
+                <a:solidFill>
+                  <a:srgbClr val="1F2A44"/>
+                </a:solidFill>
+                <a:latin typeface="Calibri"/>
+              </a:rPr>
+              <a:t> — </a:t>
+            </a:r>
+            <a:r>
+              <a:rPr sz="1100" dirty="0" err="1">
+                <a:solidFill>
+                  <a:srgbClr val="1F2A44"/>
+                </a:solidFill>
+                <a:latin typeface="Calibri"/>
+              </a:rPr>
+              <a:t>ścieżki</a:t>
+            </a:r>
+            <a:r>
+              <a:rPr sz="1100" dirty="0">
+                <a:solidFill>
+                  <a:srgbClr val="1F2A44"/>
+                </a:solidFill>
+                <a:latin typeface="Calibri"/>
+              </a:rPr>
+              <a:t> do </a:t>
+            </a:r>
+            <a:r>
+              <a:rPr sz="1100" dirty="0" err="1">
+                <a:solidFill>
+                  <a:srgbClr val="1F2A44"/>
+                </a:solidFill>
+                <a:latin typeface="Calibri"/>
+              </a:rPr>
+              <a:t>plików</a:t>
+            </a:r>
+            <a:r>
+              <a:rPr sz="1100" dirty="0">
+                <a:solidFill>
+                  <a:srgbClr val="1F2A44"/>
+                </a:solidFill>
+                <a:latin typeface="Calibri"/>
+              </a:rPr>
+              <a:t> </a:t>
+            </a:r>
+            <a:r>
+              <a:rPr sz="1100" dirty="0" err="1">
+                <a:solidFill>
+                  <a:srgbClr val="1F2A44"/>
+                </a:solidFill>
+                <a:latin typeface="Calibri"/>
+              </a:rPr>
+              <a:t>oraz</a:t>
+            </a:r>
+            <a:r>
+              <a:rPr sz="1100" dirty="0">
+                <a:solidFill>
+                  <a:srgbClr val="1F2A44"/>
+                </a:solidFill>
+                <a:latin typeface="Calibri"/>
+              </a:rPr>
+              <a:t> RANDOM_STATE = 42 (</a:t>
+            </a:r>
+            <a:r>
+              <a:rPr sz="1100" dirty="0" err="1">
+                <a:solidFill>
+                  <a:srgbClr val="1F2A44"/>
+                </a:solidFill>
+                <a:latin typeface="Calibri"/>
+              </a:rPr>
+              <a:t>jeden</a:t>
+            </a:r>
+            <a:r>
+              <a:rPr sz="1100" dirty="0">
+                <a:solidFill>
+                  <a:srgbClr val="1F2A44"/>
+                </a:solidFill>
+                <a:latin typeface="Calibri"/>
+              </a:rPr>
+              <a:t> seed </a:t>
+            </a:r>
+            <a:r>
+              <a:rPr sz="1100" dirty="0" err="1">
+                <a:solidFill>
+                  <a:srgbClr val="1F2A44"/>
+                </a:solidFill>
+                <a:latin typeface="Calibri"/>
+              </a:rPr>
+              <a:t>na</a:t>
+            </a:r>
+            <a:r>
+              <a:rPr sz="1100" dirty="0">
+                <a:solidFill>
+                  <a:srgbClr val="1F2A44"/>
+                </a:solidFill>
+                <a:latin typeface="Calibri"/>
+              </a:rPr>
+              <a:t> </a:t>
+            </a:r>
+            <a:r>
+              <a:rPr sz="1100" dirty="0" err="1">
+                <a:solidFill>
+                  <a:srgbClr val="1F2A44"/>
+                </a:solidFill>
+                <a:latin typeface="Calibri"/>
+              </a:rPr>
+              <a:t>całość</a:t>
+            </a:r>
+            <a:r>
+              <a:rPr sz="1100" dirty="0">
+                <a:solidFill>
+                  <a:srgbClr val="1F2A44"/>
+                </a:solidFill>
+                <a:latin typeface="Calibri"/>
+              </a:rPr>
+              <a:t>).</a:t>
             </a:r>
           </a:p>
           <a:p>
@@ -29169,7 +29349,7 @@
               </a:spcAft>
             </a:pPr>
             <a:r>
-              <a:rPr sz="1100" b="1">
+              <a:rPr sz="1100" b="1" dirty="0">
                 <a:solidFill>
                   <a:srgbClr val="7A1F3A"/>
                 </a:solidFill>
@@ -29178,13 +29358,130 @@
               <a:t>•  </a:t>
             </a:r>
             <a:r>
-              <a:rPr sz="1100">
-                <a:solidFill>
-                  <a:srgbClr val="1F2A44"/>
-                </a:solidFill>
-                <a:latin typeface="Calibri"/>
-              </a:rPr>
-              <a:t>src/experiment.py — definicja modeli, Pipeline, walidacja krzyżowa, eksport CSV/LaTeX.</a:t>
+              <a:rPr sz="1100" dirty="0" err="1">
+                <a:solidFill>
+                  <a:srgbClr val="1F2A44"/>
+                </a:solidFill>
+                <a:latin typeface="Calibri"/>
+              </a:rPr>
+              <a:t>src</a:t>
+            </a:r>
+            <a:r>
+              <a:rPr sz="1100" dirty="0">
+                <a:solidFill>
+                  <a:srgbClr val="1F2A44"/>
+                </a:solidFill>
+                <a:latin typeface="Calibri"/>
+              </a:rPr>
+              <a:t>/</a:t>
+            </a:r>
+            <a:r>
+              <a:rPr sz="1100" dirty="0" err="1">
+                <a:solidFill>
+                  <a:srgbClr val="1F2A44"/>
+                </a:solidFill>
+                <a:latin typeface="Calibri"/>
+              </a:rPr>
+              <a:t>experiment.py</a:t>
+            </a:r>
+            <a:r>
+              <a:rPr sz="1100" dirty="0">
+                <a:solidFill>
+                  <a:srgbClr val="1F2A44"/>
+                </a:solidFill>
+                <a:latin typeface="Calibri"/>
+              </a:rPr>
+              <a:t> — </a:t>
+            </a:r>
+            <a:r>
+              <a:rPr sz="1100" dirty="0" err="1">
+                <a:solidFill>
+                  <a:srgbClr val="1F2A44"/>
+                </a:solidFill>
+                <a:latin typeface="Calibri"/>
+              </a:rPr>
+              <a:t>definicja</a:t>
+            </a:r>
+            <a:r>
+              <a:rPr sz="1100" dirty="0">
+                <a:solidFill>
+                  <a:srgbClr val="1F2A44"/>
+                </a:solidFill>
+                <a:latin typeface="Calibri"/>
+              </a:rPr>
+              <a:t> </a:t>
+            </a:r>
+            <a:r>
+              <a:rPr sz="1100" dirty="0" err="1">
+                <a:solidFill>
+                  <a:srgbClr val="1F2A44"/>
+                </a:solidFill>
+                <a:latin typeface="Calibri"/>
+              </a:rPr>
+              <a:t>modeli</a:t>
+            </a:r>
+            <a:r>
+              <a:rPr sz="1100" dirty="0">
+                <a:solidFill>
+                  <a:srgbClr val="1F2A44"/>
+                </a:solidFill>
+                <a:latin typeface="Calibri"/>
+              </a:rPr>
+              <a:t>, Pipeline, </a:t>
+            </a:r>
+            <a:r>
+              <a:rPr sz="1100" dirty="0" err="1">
+                <a:solidFill>
+                  <a:srgbClr val="1F2A44"/>
+                </a:solidFill>
+                <a:latin typeface="Calibri"/>
+              </a:rPr>
+              <a:t>walidacja</a:t>
+            </a:r>
+            <a:r>
+              <a:rPr sz="1100" dirty="0">
+                <a:solidFill>
+                  <a:srgbClr val="1F2A44"/>
+                </a:solidFill>
+                <a:latin typeface="Calibri"/>
+              </a:rPr>
+              <a:t> </a:t>
+            </a:r>
+            <a:r>
+              <a:rPr sz="1100" dirty="0" err="1">
+                <a:solidFill>
+                  <a:srgbClr val="1F2A44"/>
+                </a:solidFill>
+                <a:latin typeface="Calibri"/>
+              </a:rPr>
+              <a:t>krzyżowa</a:t>
+            </a:r>
+            <a:r>
+              <a:rPr sz="1100" dirty="0">
+                <a:solidFill>
+                  <a:srgbClr val="1F2A44"/>
+                </a:solidFill>
+                <a:latin typeface="Calibri"/>
+              </a:rPr>
+              <a:t>, </a:t>
+            </a:r>
+            <a:r>
+              <a:rPr sz="1100" dirty="0" err="1">
+                <a:solidFill>
+                  <a:srgbClr val="1F2A44"/>
+                </a:solidFill>
+                <a:latin typeface="Calibri"/>
+              </a:rPr>
+              <a:t>eksport</a:t>
+            </a:r>
+            <a:r>
+              <a:rPr sz="1100" dirty="0">
+                <a:solidFill>
+                  <a:srgbClr val="1F2A44"/>
+                </a:solidFill>
+                <a:latin typeface="Calibri"/>
+              </a:rPr>
+              <a:t> CSV/LaTeX.</a:t>
             </a:r>
           </a:p>
           <a:p>
@@ -29197,7 +29494,7 @@
               </a:spcAft>
             </a:pPr>
             <a:r>
-              <a:rPr sz="1100" b="1">
+              <a:rPr sz="1100" b="1" dirty="0">
                 <a:solidFill>
                   <a:srgbClr val="7A1F3A"/>
                 </a:solidFill>
@@ -29206,13 +29503,148 @@
               <a:t>•  </a:t>
             </a:r>
             <a:r>
-              <a:rPr sz="1100">
-                <a:solidFill>
-                  <a:srgbClr val="1F2A44"/>
-                </a:solidFill>
-                <a:latin typeface="Calibri"/>
-              </a:rPr>
-              <a:t>src/wykresy.py — wykresy Plotly (rozkład klas, korelacje, porównanie, agregaty).</a:t>
+              <a:rPr sz="1100" dirty="0" err="1">
+                <a:solidFill>
+                  <a:srgbClr val="1F2A44"/>
+                </a:solidFill>
+                <a:latin typeface="Calibri"/>
+              </a:rPr>
+              <a:t>src</a:t>
+            </a:r>
+            <a:r>
+              <a:rPr sz="1100" dirty="0">
+                <a:solidFill>
+                  <a:srgbClr val="1F2A44"/>
+                </a:solidFill>
+                <a:latin typeface="Calibri"/>
+              </a:rPr>
+              <a:t>/</a:t>
+            </a:r>
+            <a:r>
+              <a:rPr sz="1100" dirty="0" err="1">
+                <a:solidFill>
+                  <a:srgbClr val="1F2A44"/>
+                </a:solidFill>
+                <a:latin typeface="Calibri"/>
+              </a:rPr>
+              <a:t>wykresy.py</a:t>
+            </a:r>
+            <a:r>
+              <a:rPr sz="1100" dirty="0">
+                <a:solidFill>
+                  <a:srgbClr val="1F2A44"/>
+                </a:solidFill>
+                <a:latin typeface="Calibri"/>
+              </a:rPr>
+              <a:t> — </a:t>
+            </a:r>
+            <a:r>
+              <a:rPr sz="1100" dirty="0" err="1">
+                <a:solidFill>
+                  <a:srgbClr val="1F2A44"/>
+                </a:solidFill>
+                <a:latin typeface="Calibri"/>
+              </a:rPr>
+              <a:t>wykresy</a:t>
+            </a:r>
+            <a:r>
+              <a:rPr sz="1100" dirty="0">
+                <a:solidFill>
+                  <a:srgbClr val="1F2A44"/>
+                </a:solidFill>
+                <a:latin typeface="Calibri"/>
+              </a:rPr>
+              <a:t> Plotly (</a:t>
+            </a:r>
+            <a:r>
+              <a:rPr sz="1100" dirty="0" err="1">
+                <a:solidFill>
+                  <a:srgbClr val="1F2A44"/>
+                </a:solidFill>
+                <a:latin typeface="Calibri"/>
+              </a:rPr>
+              <a:t>rozkład</a:t>
+            </a:r>
+            <a:r>
+              <a:rPr sz="1100" dirty="0">
+                <a:solidFill>
+                  <a:srgbClr val="1F2A44"/>
+                </a:solidFill>
+                <a:latin typeface="Calibri"/>
+              </a:rPr>
+              <a:t> </a:t>
+            </a:r>
+            <a:r>
+              <a:rPr sz="1100" dirty="0" err="1">
+                <a:solidFill>
+                  <a:srgbClr val="1F2A44"/>
+                </a:solidFill>
+                <a:latin typeface="Calibri"/>
+              </a:rPr>
+              <a:t>klas</a:t>
+            </a:r>
+            <a:r>
+              <a:rPr sz="1100" dirty="0">
+                <a:solidFill>
+                  <a:srgbClr val="1F2A44"/>
+                </a:solidFill>
+                <a:latin typeface="Calibri"/>
+              </a:rPr>
+              <a:t>, </a:t>
+            </a:r>
+            <a:r>
+              <a:rPr sz="1100" dirty="0" err="1">
+                <a:solidFill>
+                  <a:srgbClr val="1F2A44"/>
+                </a:solidFill>
+                <a:latin typeface="Calibri"/>
+              </a:rPr>
+              <a:t>korelacje</a:t>
+            </a:r>
+            <a:r>
+              <a:rPr sz="1100" dirty="0">
+                <a:solidFill>
+                  <a:srgbClr val="1F2A44"/>
+                </a:solidFill>
+                <a:latin typeface="Calibri"/>
+              </a:rPr>
+              <a:t>, </a:t>
+            </a:r>
+            <a:r>
+              <a:rPr sz="1100" dirty="0" err="1">
+                <a:solidFill>
+                  <a:srgbClr val="1F2A44"/>
+                </a:solidFill>
+                <a:latin typeface="Calibri"/>
+              </a:rPr>
+              <a:t>porównanie</a:t>
+            </a:r>
+            <a:r>
+              <a:rPr sz="1100" dirty="0">
+                <a:solidFill>
+                  <a:srgbClr val="1F2A44"/>
+                </a:solidFill>
+                <a:latin typeface="Calibri"/>
+              </a:rPr>
+              <a:t>, </a:t>
+            </a:r>
+            <a:r>
+              <a:rPr sz="1100" dirty="0" err="1">
+                <a:solidFill>
+                  <a:srgbClr val="1F2A44"/>
+                </a:solidFill>
+                <a:latin typeface="Calibri"/>
+              </a:rPr>
+              <a:t>agregaty</a:t>
+            </a:r>
+            <a:r>
+              <a:rPr sz="1100" dirty="0">
+                <a:solidFill>
+                  <a:srgbClr val="1F2A44"/>
+                </a:solidFill>
+                <a:latin typeface="Calibri"/>
+              </a:rPr>
+              <a:t>).</a:t>
             </a:r>
           </a:p>
           <a:p>
@@ -29225,7 +29657,7 @@
               </a:spcAft>
             </a:pPr>
             <a:r>
-              <a:rPr sz="1100" b="1">
+              <a:rPr sz="1100" b="1" dirty="0">
                 <a:solidFill>
                   <a:srgbClr val="7A1F3A"/>
                 </a:solidFill>
@@ -29234,13 +29666,58 @@
               <a:t>•  </a:t>
             </a:r>
             <a:r>
-              <a:rPr sz="1100">
-                <a:solidFill>
-                  <a:srgbClr val="1F2A44"/>
-                </a:solidFill>
-                <a:latin typeface="Calibri"/>
-              </a:rPr>
-              <a:t>streamlit_app.py — aplikacja WWW z 4 zakładkami.</a:t>
+              <a:rPr sz="1100" dirty="0" err="1">
+                <a:solidFill>
+                  <a:srgbClr val="1F2A44"/>
+                </a:solidFill>
+                <a:latin typeface="Calibri"/>
+              </a:rPr>
+              <a:t>streamlit_app.py</a:t>
+            </a:r>
+            <a:r>
+              <a:rPr sz="1100" dirty="0">
+                <a:solidFill>
+                  <a:srgbClr val="1F2A44"/>
+                </a:solidFill>
+                <a:latin typeface="Calibri"/>
+              </a:rPr>
+              <a:t> — </a:t>
+            </a:r>
+            <a:r>
+              <a:rPr sz="1100" dirty="0" err="1">
+                <a:solidFill>
+                  <a:srgbClr val="1F2A44"/>
+                </a:solidFill>
+                <a:latin typeface="Calibri"/>
+              </a:rPr>
+              <a:t>aplikacja</a:t>
+            </a:r>
+            <a:r>
+              <a:rPr sz="1100" dirty="0">
+                <a:solidFill>
+                  <a:srgbClr val="1F2A44"/>
+                </a:solidFill>
+                <a:latin typeface="Calibri"/>
+              </a:rPr>
+              <a:t> WWW z 4 </a:t>
+            </a:r>
+            <a:r>
+              <a:rPr sz="1100" dirty="0" err="1">
+                <a:solidFill>
+                  <a:srgbClr val="1F2A44"/>
+                </a:solidFill>
+                <a:latin typeface="Calibri"/>
+              </a:rPr>
+              <a:t>zakładkami</a:t>
+            </a:r>
+            <a:r>
+              <a:rPr sz="1100" dirty="0">
+                <a:solidFill>
+                  <a:srgbClr val="1F2A44"/>
+                </a:solidFill>
+                <a:latin typeface="Calibri"/>
+              </a:rPr>
+              <a:t>.</a:t>
             </a:r>
           </a:p>
         </p:txBody>

</xml_diff>